<commit_message>
comitting just a number of changes to the examples
</commit_message>
<xml_diff>
--- a/small_examples/Forecasting Overview.pptx
+++ b/small_examples/Forecasting Overview.pptx
@@ -6,6 +6,8 @@
   </p:sldMasterIdLst>
   <p:sldIdLst>
     <p:sldId id="256" r:id="rId2"/>
+    <p:sldId id="257" r:id="rId3"/>
+    <p:sldId id="258" r:id="rId4"/>
   </p:sldIdLst>
   <p:sldSz cx="12192000" cy="6858000"/>
   <p:notesSz cx="6858000" cy="9144000"/>
@@ -104,6 +106,11 @@
       </a:defRPr>
     </a:lvl9pPr>
   </p:defaultTextStyle>
+  <p:extLst>
+    <p:ext uri="{EFAFB233-063F-42B5-8137-9DF3F51BA10A}">
+      <p15:sldGuideLst xmlns:p15="http://schemas.microsoft.com/office/powerpoint/2012/main"/>
+    </p:ext>
+  </p:extLst>
 </p:presentation>
 </file>
 
@@ -256,7 +263,7 @@
           <a:p>
             <a:fld id="{72F29D56-7974-42DD-839F-B466F4B92567}" type="datetimeFigureOut">
               <a:rPr lang="en-AT" smtClean="0"/>
-              <a:t>08/01/2024</a:t>
+              <a:t>07/10/2024</a:t>
             </a:fld>
             <a:endParaRPr lang="en-AT"/>
           </a:p>
@@ -456,7 +463,7 @@
           <a:p>
             <a:fld id="{72F29D56-7974-42DD-839F-B466F4B92567}" type="datetimeFigureOut">
               <a:rPr lang="en-AT" smtClean="0"/>
-              <a:t>08/01/2024</a:t>
+              <a:t>07/10/2024</a:t>
             </a:fld>
             <a:endParaRPr lang="en-AT"/>
           </a:p>
@@ -666,7 +673,7 @@
           <a:p>
             <a:fld id="{72F29D56-7974-42DD-839F-B466F4B92567}" type="datetimeFigureOut">
               <a:rPr lang="en-AT" smtClean="0"/>
-              <a:t>08/01/2024</a:t>
+              <a:t>07/10/2024</a:t>
             </a:fld>
             <a:endParaRPr lang="en-AT"/>
           </a:p>
@@ -866,7 +873,7 @@
           <a:p>
             <a:fld id="{72F29D56-7974-42DD-839F-B466F4B92567}" type="datetimeFigureOut">
               <a:rPr lang="en-AT" smtClean="0"/>
-              <a:t>08/01/2024</a:t>
+              <a:t>07/10/2024</a:t>
             </a:fld>
             <a:endParaRPr lang="en-AT"/>
           </a:p>
@@ -1142,7 +1149,7 @@
           <a:p>
             <a:fld id="{72F29D56-7974-42DD-839F-B466F4B92567}" type="datetimeFigureOut">
               <a:rPr lang="en-AT" smtClean="0"/>
-              <a:t>08/01/2024</a:t>
+              <a:t>07/10/2024</a:t>
             </a:fld>
             <a:endParaRPr lang="en-AT"/>
           </a:p>
@@ -1410,7 +1417,7 @@
           <a:p>
             <a:fld id="{72F29D56-7974-42DD-839F-B466F4B92567}" type="datetimeFigureOut">
               <a:rPr lang="en-AT" smtClean="0"/>
-              <a:t>08/01/2024</a:t>
+              <a:t>07/10/2024</a:t>
             </a:fld>
             <a:endParaRPr lang="en-AT"/>
           </a:p>
@@ -1825,7 +1832,7 @@
           <a:p>
             <a:fld id="{72F29D56-7974-42DD-839F-B466F4B92567}" type="datetimeFigureOut">
               <a:rPr lang="en-AT" smtClean="0"/>
-              <a:t>08/01/2024</a:t>
+              <a:t>07/10/2024</a:t>
             </a:fld>
             <a:endParaRPr lang="en-AT"/>
           </a:p>
@@ -1967,7 +1974,7 @@
           <a:p>
             <a:fld id="{72F29D56-7974-42DD-839F-B466F4B92567}" type="datetimeFigureOut">
               <a:rPr lang="en-AT" smtClean="0"/>
-              <a:t>08/01/2024</a:t>
+              <a:t>07/10/2024</a:t>
             </a:fld>
             <a:endParaRPr lang="en-AT"/>
           </a:p>
@@ -2080,7 +2087,7 @@
           <a:p>
             <a:fld id="{72F29D56-7974-42DD-839F-B466F4B92567}" type="datetimeFigureOut">
               <a:rPr lang="en-AT" smtClean="0"/>
-              <a:t>08/01/2024</a:t>
+              <a:t>07/10/2024</a:t>
             </a:fld>
             <a:endParaRPr lang="en-AT"/>
           </a:p>
@@ -2393,7 +2400,7 @@
           <a:p>
             <a:fld id="{72F29D56-7974-42DD-839F-B466F4B92567}" type="datetimeFigureOut">
               <a:rPr lang="en-AT" smtClean="0"/>
-              <a:t>08/01/2024</a:t>
+              <a:t>07/10/2024</a:t>
             </a:fld>
             <a:endParaRPr lang="en-AT"/>
           </a:p>
@@ -2682,7 +2689,7 @@
           <a:p>
             <a:fld id="{72F29D56-7974-42DD-839F-B466F4B92567}" type="datetimeFigureOut">
               <a:rPr lang="en-AT" smtClean="0"/>
-              <a:t>08/01/2024</a:t>
+              <a:t>07/10/2024</a:t>
             </a:fld>
             <a:endParaRPr lang="en-AT"/>
           </a:p>
@@ -2925,7 +2932,7 @@
           <a:p>
             <a:fld id="{72F29D56-7974-42DD-839F-B466F4B92567}" type="datetimeFigureOut">
               <a:rPr lang="en-AT" smtClean="0"/>
-              <a:t>08/01/2024</a:t>
+              <a:t>07/10/2024</a:t>
             </a:fld>
             <a:endParaRPr lang="en-AT"/>
           </a:p>
@@ -3653,6 +3660,816 @@
 </p:sld>
 </file>
 
+<file path=ppt/slides/slide2.xml><?xml version="1.0" encoding="utf-8"?>
+<p:sld xmlns:a="http://schemas.openxmlformats.org/drawingml/2006/main" xmlns:r="http://schemas.openxmlformats.org/officeDocument/2006/relationships" xmlns:p="http://schemas.openxmlformats.org/presentationml/2006/main">
+  <p:cSld>
+    <p:spTree>
+      <p:nvGrpSpPr>
+        <p:cNvPr id="1" name=""/>
+        <p:cNvGrpSpPr/>
+        <p:nvPr/>
+      </p:nvGrpSpPr>
+      <p:grpSpPr>
+        <a:xfrm>
+          <a:off x="0" y="0"/>
+          <a:ext cx="0" cy="0"/>
+          <a:chOff x="0" y="0"/>
+          <a:chExt cx="0" cy="0"/>
+        </a:xfrm>
+      </p:grpSpPr>
+      <p:sp>
+        <p:nvSpPr>
+          <p:cNvPr id="3" name="Content Placeholder 2">
+            <a:extLst>
+              <a:ext uri="{FF2B5EF4-FFF2-40B4-BE49-F238E27FC236}">
+                <a16:creationId xmlns:a16="http://schemas.microsoft.com/office/drawing/2014/main" id="{EC2AD76B-CD6B-7AAA-8D17-529E2C5A2347}"/>
+              </a:ext>
+            </a:extLst>
+          </p:cNvPr>
+          <p:cNvSpPr>
+            <a:spLocks noGrp="1"/>
+          </p:cNvSpPr>
+          <p:nvPr>
+            <p:ph idx="1"/>
+          </p:nvPr>
+        </p:nvSpPr>
+        <p:spPr>
+          <a:xfrm>
+            <a:off x="838200" y="370936"/>
+            <a:ext cx="10515600" cy="5806027"/>
+          </a:xfrm>
+        </p:spPr>
+        <p:txBody>
+          <a:bodyPr>
+            <a:normAutofit fontScale="92500" lnSpcReduction="20000"/>
+          </a:bodyPr>
+          <a:lstStyle/>
+          <a:p>
+            <a:r>
+              <a:rPr lang="en-GB" dirty="0"/>
+              <a:t>Forecast exogenous values</a:t>
+            </a:r>
+          </a:p>
+          <a:p>
+            <a:r>
+              <a:rPr lang="en-GB" dirty="0"/>
+              <a:t>Nowcast </a:t>
+            </a:r>
+          </a:p>
+          <a:p>
+            <a:pPr lvl="1"/>
+            <a:r>
+              <a:rPr lang="en-GB" dirty="0"/>
+              <a:t>Check across all data what the final observation is (in </a:t>
+            </a:r>
+            <a:r>
+              <a:rPr lang="en-GB" dirty="0" err="1"/>
+              <a:t>processed_input_data</a:t>
+            </a:r>
+            <a:r>
+              <a:rPr lang="en-GB" dirty="0"/>
+              <a:t>)</a:t>
+            </a:r>
+          </a:p>
+          <a:p>
+            <a:pPr lvl="1"/>
+            <a:r>
+              <a:rPr lang="en-GB" dirty="0"/>
+              <a:t>Check for which dependent variables we then need to nowcast and for which time frame (</a:t>
+            </a:r>
+            <a:r>
+              <a:rPr lang="en-GB" dirty="0" err="1"/>
+              <a:t>cur_target_dates</a:t>
+            </a:r>
+            <a:r>
+              <a:rPr lang="en-GB" dirty="0"/>
+              <a:t>)</a:t>
+            </a:r>
+          </a:p>
+          <a:p>
+            <a:pPr lvl="2"/>
+            <a:r>
+              <a:rPr lang="en-GB" dirty="0"/>
+              <a:t>If estimated: get independent variables</a:t>
+            </a:r>
+          </a:p>
+          <a:p>
+            <a:pPr lvl="3"/>
+            <a:r>
+              <a:rPr lang="en-GB" dirty="0">
+                <a:solidFill>
+                  <a:srgbClr val="FF0000"/>
+                </a:solidFill>
+              </a:rPr>
+              <a:t>Check whether any of the independent variables need to be replaced by forecasted exogenous values</a:t>
+            </a:r>
+          </a:p>
+          <a:p>
+            <a:pPr lvl="3"/>
+            <a:r>
+              <a:rPr lang="en-GB" dirty="0"/>
+              <a:t>Set-up nowcast </a:t>
+            </a:r>
+          </a:p>
+          <a:p>
+            <a:pPr lvl="3"/>
+            <a:r>
+              <a:rPr lang="en-GB" dirty="0"/>
+              <a:t>Nowcast using </a:t>
+            </a:r>
+            <a:r>
+              <a:rPr lang="en-GB" dirty="0" err="1"/>
+              <a:t>predict.isat</a:t>
+            </a:r>
+            <a:endParaRPr lang="en-GB" dirty="0"/>
+          </a:p>
+          <a:p>
+            <a:pPr lvl="2"/>
+            <a:r>
+              <a:rPr lang="en-GB" dirty="0"/>
+              <a:t>If identity: </a:t>
+            </a:r>
+          </a:p>
+          <a:p>
+            <a:pPr lvl="3"/>
+            <a:r>
+              <a:rPr lang="en-GB" dirty="0"/>
+              <a:t>check where identity is NA but the elements of the NA are available (i.e. where the co-variates are available) </a:t>
+            </a:r>
+          </a:p>
+          <a:p>
+            <a:pPr lvl="3"/>
+            <a:r>
+              <a:rPr lang="en-GB" dirty="0"/>
+              <a:t>Check where exogenous co-variates themselves are not available – we can get them from the exogenous forecasts</a:t>
+            </a:r>
+          </a:p>
+          <a:p>
+            <a:r>
+              <a:rPr lang="en-GB" dirty="0"/>
+              <a:t>Predict future values (</a:t>
+            </a:r>
+            <a:r>
+              <a:rPr lang="en-GB" dirty="0" err="1"/>
+              <a:t>isat</a:t>
+            </a:r>
+            <a:r>
+              <a:rPr lang="en-GB" dirty="0"/>
+              <a:t>)</a:t>
+            </a:r>
+          </a:p>
+          <a:p>
+            <a:pPr lvl="1"/>
+            <a:r>
+              <a:rPr lang="en-GB" dirty="0"/>
+              <a:t>Estimated</a:t>
+            </a:r>
+          </a:p>
+          <a:p>
+            <a:pPr lvl="2"/>
+            <a:r>
+              <a:rPr lang="en-GB" dirty="0"/>
+              <a:t>Central</a:t>
+            </a:r>
+          </a:p>
+          <a:p>
+            <a:pPr lvl="2"/>
+            <a:r>
+              <a:rPr lang="en-GB" dirty="0"/>
+              <a:t>Uncertainty</a:t>
+            </a:r>
+          </a:p>
+          <a:p>
+            <a:pPr lvl="1"/>
+            <a:r>
+              <a:rPr lang="en-GB" dirty="0"/>
+              <a:t>Identity</a:t>
+            </a:r>
+          </a:p>
+        </p:txBody>
+      </p:sp>
+    </p:spTree>
+    <p:extLst>
+      <p:ext uri="{BB962C8B-B14F-4D97-AF65-F5344CB8AC3E}">
+        <p14:creationId xmlns:p14="http://schemas.microsoft.com/office/powerpoint/2010/main" val="3657261990"/>
+      </p:ext>
+    </p:extLst>
+  </p:cSld>
+  <p:clrMapOvr>
+    <a:masterClrMapping/>
+  </p:clrMapOvr>
+</p:sld>
+</file>
+
+<file path=ppt/slides/slide3.xml><?xml version="1.0" encoding="utf-8"?>
+<p:sld xmlns:a="http://schemas.openxmlformats.org/drawingml/2006/main" xmlns:r="http://schemas.openxmlformats.org/officeDocument/2006/relationships" xmlns:p="http://schemas.openxmlformats.org/presentationml/2006/main">
+  <p:cSld>
+    <p:spTree>
+      <p:nvGrpSpPr>
+        <p:cNvPr id="1" name=""/>
+        <p:cNvGrpSpPr/>
+        <p:nvPr/>
+      </p:nvGrpSpPr>
+      <p:grpSpPr>
+        <a:xfrm>
+          <a:off x="0" y="0"/>
+          <a:ext cx="0" cy="0"/>
+          <a:chOff x="0" y="0"/>
+          <a:chExt cx="0" cy="0"/>
+        </a:xfrm>
+      </p:grpSpPr>
+      <p:sp>
+        <p:nvSpPr>
+          <p:cNvPr id="2" name="Title 1">
+            <a:extLst>
+              <a:ext uri="{FF2B5EF4-FFF2-40B4-BE49-F238E27FC236}">
+                <a16:creationId xmlns:a16="http://schemas.microsoft.com/office/drawing/2014/main" id="{14FBE222-1A71-E80C-CC18-7A9CD4D77E0D}"/>
+              </a:ext>
+            </a:extLst>
+          </p:cNvPr>
+          <p:cNvSpPr>
+            <a:spLocks noGrp="1"/>
+          </p:cNvSpPr>
+          <p:nvPr>
+            <p:ph type="title"/>
+          </p:nvPr>
+        </p:nvSpPr>
+        <p:spPr/>
+        <p:txBody>
+          <a:bodyPr/>
+          <a:lstStyle/>
+          <a:p>
+            <a:r>
+              <a:rPr lang="en-GB" dirty="0"/>
+              <a:t>Nowcasting</a:t>
+            </a:r>
+          </a:p>
+        </p:txBody>
+      </p:sp>
+      <mc:AlternateContent xmlns:mc="http://schemas.openxmlformats.org/markup-compatibility/2006" xmlns:a14="http://schemas.microsoft.com/office/drawing/2010/main">
+        <mc:Choice Requires="a14">
+          <p:sp>
+            <p:nvSpPr>
+              <p:cNvPr id="3" name="Content Placeholder 2">
+                <a:extLst>
+                  <a:ext uri="{FF2B5EF4-FFF2-40B4-BE49-F238E27FC236}">
+                    <a16:creationId xmlns:a16="http://schemas.microsoft.com/office/drawing/2014/main" id="{60EBC197-E8FD-D126-2B4E-7651A173415A}"/>
+                  </a:ext>
+                </a:extLst>
+              </p:cNvPr>
+              <p:cNvSpPr>
+                <a:spLocks noGrp="1"/>
+              </p:cNvSpPr>
+              <p:nvPr>
+                <p:ph idx="1"/>
+              </p:nvPr>
+            </p:nvSpPr>
+            <p:spPr/>
+            <p:txBody>
+              <a:bodyPr/>
+              <a:lstStyle/>
+              <a:p>
+                <a:pPr marL="0" indent="0">
+                  <a:buNone/>
+                </a:pPr>
+                <a14:m>
+                  <m:oMath xmlns:m="http://schemas.openxmlformats.org/officeDocument/2006/math">
+                    <m:r>
+                      <a:rPr lang="en-GB" b="0" i="1" smtClean="0">
+                        <a:latin typeface="Cambria Math" panose="02040503050406030204" pitchFamily="18" charset="0"/>
+                      </a:rPr>
+                      <m:t>𝑎</m:t>
+                    </m:r>
+                    <m:r>
+                      <a:rPr lang="en-GB" b="0" i="1" smtClean="0">
+                        <a:latin typeface="Cambria Math" panose="02040503050406030204" pitchFamily="18" charset="0"/>
+                      </a:rPr>
+                      <m:t>=</m:t>
+                    </m:r>
+                    <m:r>
+                      <a:rPr lang="en-GB" b="0" i="1" smtClean="0">
+                        <a:latin typeface="Cambria Math" panose="02040503050406030204" pitchFamily="18" charset="0"/>
+                      </a:rPr>
+                      <m:t>𝑏</m:t>
+                    </m:r>
+                    <m:r>
+                      <a:rPr lang="en-GB" b="0" i="1" smtClean="0">
+                        <a:latin typeface="Cambria Math" panose="02040503050406030204" pitchFamily="18" charset="0"/>
+                      </a:rPr>
+                      <m:t>+</m:t>
+                    </m:r>
+                    <m:r>
+                      <a:rPr lang="en-GB" b="0" i="1" smtClean="0">
+                        <a:latin typeface="Cambria Math" panose="02040503050406030204" pitchFamily="18" charset="0"/>
+                      </a:rPr>
+                      <m:t>𝑐</m:t>
+                    </m:r>
+                  </m:oMath>
+                </a14:m>
+                <a:r>
+                  <a:rPr lang="en-GB" dirty="0"/>
+                  <a:t> for </a:t>
+                </a:r>
+                <a14:m>
+                  <m:oMath xmlns:m="http://schemas.openxmlformats.org/officeDocument/2006/math">
+                    <m:sSub>
+                      <m:sSubPr>
+                        <m:ctrlPr>
+                          <a:rPr lang="en-GB" b="0" i="1" smtClean="0">
+                            <a:latin typeface="Cambria Math" panose="02040503050406030204" pitchFamily="18" charset="0"/>
+                          </a:rPr>
+                        </m:ctrlPr>
+                      </m:sSubPr>
+                      <m:e>
+                        <m:r>
+                          <a:rPr lang="en-GB" b="0" i="1" smtClean="0">
+                            <a:latin typeface="Cambria Math" panose="02040503050406030204" pitchFamily="18" charset="0"/>
+                          </a:rPr>
+                          <m:t>𝑡</m:t>
+                        </m:r>
+                      </m:e>
+                      <m:sub>
+                        <m:r>
+                          <a:rPr lang="en-GB" b="0" i="1" smtClean="0">
+                            <a:latin typeface="Cambria Math" panose="02040503050406030204" pitchFamily="18" charset="0"/>
+                          </a:rPr>
+                          <m:t>1</m:t>
+                        </m:r>
+                      </m:sub>
+                    </m:sSub>
+                    <m:r>
+                      <a:rPr lang="en-GB" b="0" i="0" smtClean="0">
+                        <a:latin typeface="Cambria Math" panose="02040503050406030204" pitchFamily="18" charset="0"/>
+                      </a:rPr>
+                      <m:t>…</m:t>
+                    </m:r>
+                    <m:sSub>
+                      <m:sSubPr>
+                        <m:ctrlPr>
+                          <a:rPr lang="en-GB" b="0" i="1" smtClean="0">
+                            <a:latin typeface="Cambria Math" panose="02040503050406030204" pitchFamily="18" charset="0"/>
+                          </a:rPr>
+                        </m:ctrlPr>
+                      </m:sSubPr>
+                      <m:e>
+                        <m:r>
+                          <m:rPr>
+                            <m:sty m:val="p"/>
+                          </m:rPr>
+                          <a:rPr lang="en-GB" b="0" i="0" smtClean="0">
+                            <a:latin typeface="Cambria Math" panose="02040503050406030204" pitchFamily="18" charset="0"/>
+                          </a:rPr>
+                          <m:t>t</m:t>
+                        </m:r>
+                      </m:e>
+                      <m:sub>
+                        <m:r>
+                          <a:rPr lang="en-GB" b="0" i="0" smtClean="0">
+                            <a:latin typeface="Cambria Math" panose="02040503050406030204" pitchFamily="18" charset="0"/>
+                          </a:rPr>
+                          <m:t>10</m:t>
+                        </m:r>
+                      </m:sub>
+                    </m:sSub>
+                  </m:oMath>
+                </a14:m>
+                <a:endParaRPr lang="en-GB" dirty="0"/>
+              </a:p>
+              <a:p>
+                <a:pPr marL="0" indent="0">
+                  <a:buNone/>
+                </a:pPr>
+                <a:endParaRPr lang="en-GB" dirty="0"/>
+              </a:p>
+              <a:p>
+                <a:pPr marL="0" indent="0">
+                  <a:buNone/>
+                </a:pPr>
+                <a14:m>
+                  <m:oMath xmlns:m="http://schemas.openxmlformats.org/officeDocument/2006/math">
+                    <m:r>
+                      <a:rPr lang="en-GB" b="0" i="1" smtClean="0">
+                        <a:latin typeface="Cambria Math" panose="02040503050406030204" pitchFamily="18" charset="0"/>
+                      </a:rPr>
+                      <m:t>𝑑</m:t>
+                    </m:r>
+                    <m:r>
+                      <a:rPr lang="en-GB" b="0" i="1" smtClean="0">
+                        <a:latin typeface="Cambria Math" panose="02040503050406030204" pitchFamily="18" charset="0"/>
+                      </a:rPr>
+                      <m:t>=</m:t>
+                    </m:r>
+                    <m:r>
+                      <a:rPr lang="en-GB" b="0" i="1" smtClean="0">
+                        <a:latin typeface="Cambria Math" panose="02040503050406030204" pitchFamily="18" charset="0"/>
+                      </a:rPr>
+                      <m:t>𝑒</m:t>
+                    </m:r>
+                    <m:r>
+                      <a:rPr lang="en-GB" b="0" i="1" smtClean="0">
+                        <a:latin typeface="Cambria Math" panose="02040503050406030204" pitchFamily="18" charset="0"/>
+                      </a:rPr>
+                      <m:t>+</m:t>
+                    </m:r>
+                    <m:r>
+                      <a:rPr lang="en-GB" b="0" i="1" smtClean="0">
+                        <a:latin typeface="Cambria Math" panose="02040503050406030204" pitchFamily="18" charset="0"/>
+                      </a:rPr>
+                      <m:t>𝑎</m:t>
+                    </m:r>
+                  </m:oMath>
+                </a14:m>
+                <a:r>
+                  <a:rPr lang="en-GB" dirty="0"/>
+                  <a:t> for </a:t>
+                </a:r>
+                <a14:m>
+                  <m:oMath xmlns:m="http://schemas.openxmlformats.org/officeDocument/2006/math">
+                    <m:sSub>
+                      <m:sSubPr>
+                        <m:ctrlPr>
+                          <a:rPr lang="en-GB" b="0" i="1" smtClean="0">
+                            <a:latin typeface="Cambria Math" panose="02040503050406030204" pitchFamily="18" charset="0"/>
+                          </a:rPr>
+                        </m:ctrlPr>
+                      </m:sSubPr>
+                      <m:e>
+                        <m:r>
+                          <a:rPr lang="en-GB" b="0" i="1" smtClean="0">
+                            <a:latin typeface="Cambria Math" panose="02040503050406030204" pitchFamily="18" charset="0"/>
+                          </a:rPr>
+                          <m:t>𝑡</m:t>
+                        </m:r>
+                      </m:e>
+                      <m:sub>
+                        <m:r>
+                          <a:rPr lang="en-GB" b="0" i="1" smtClean="0">
+                            <a:latin typeface="Cambria Math" panose="02040503050406030204" pitchFamily="18" charset="0"/>
+                          </a:rPr>
+                          <m:t>1</m:t>
+                        </m:r>
+                      </m:sub>
+                    </m:sSub>
+                    <m:r>
+                      <a:rPr lang="en-GB" b="0" i="0" smtClean="0">
+                        <a:latin typeface="Cambria Math" panose="02040503050406030204" pitchFamily="18" charset="0"/>
+                      </a:rPr>
+                      <m:t>…</m:t>
+                    </m:r>
+                    <m:sSub>
+                      <m:sSubPr>
+                        <m:ctrlPr>
+                          <a:rPr lang="en-GB" b="0" i="1" smtClean="0">
+                            <a:latin typeface="Cambria Math" panose="02040503050406030204" pitchFamily="18" charset="0"/>
+                          </a:rPr>
+                        </m:ctrlPr>
+                      </m:sSubPr>
+                      <m:e>
+                        <m:r>
+                          <m:rPr>
+                            <m:sty m:val="p"/>
+                          </m:rPr>
+                          <a:rPr lang="en-GB" b="0" i="0" smtClean="0">
+                            <a:latin typeface="Cambria Math" panose="02040503050406030204" pitchFamily="18" charset="0"/>
+                          </a:rPr>
+                          <m:t>t</m:t>
+                        </m:r>
+                      </m:e>
+                      <m:sub>
+                        <m:r>
+                          <a:rPr lang="en-GB" b="0" i="0" smtClean="0">
+                            <a:latin typeface="Cambria Math" panose="02040503050406030204" pitchFamily="18" charset="0"/>
+                          </a:rPr>
+                          <m:t>9</m:t>
+                        </m:r>
+                      </m:sub>
+                    </m:sSub>
+                  </m:oMath>
+                </a14:m>
+                <a:endParaRPr lang="en-GB" dirty="0"/>
+              </a:p>
+              <a:p>
+                <a:pPr marL="0" indent="0">
+                  <a:buNone/>
+                </a:pPr>
+                <a:endParaRPr lang="en-GB" dirty="0"/>
+              </a:p>
+              <a:p>
+                <a:r>
+                  <a:rPr lang="en-GB" dirty="0"/>
+                  <a:t>Case 1: </a:t>
+                </a:r>
+                <a14:m>
+                  <m:oMath xmlns:m="http://schemas.openxmlformats.org/officeDocument/2006/math">
+                    <m:sSub>
+                      <m:sSubPr>
+                        <m:ctrlPr>
+                          <a:rPr lang="en-GB" b="0" i="1" smtClean="0">
+                            <a:latin typeface="Cambria Math" panose="02040503050406030204" pitchFamily="18" charset="0"/>
+                          </a:rPr>
+                        </m:ctrlPr>
+                      </m:sSubPr>
+                      <m:e>
+                        <m:r>
+                          <a:rPr lang="en-GB" b="0" i="1" smtClean="0">
+                            <a:latin typeface="Cambria Math" panose="02040503050406030204" pitchFamily="18" charset="0"/>
+                          </a:rPr>
+                          <m:t>𝑑</m:t>
+                        </m:r>
+                      </m:e>
+                      <m:sub>
+                        <m:r>
+                          <a:rPr lang="en-GB" b="0" i="1" smtClean="0">
+                            <a:latin typeface="Cambria Math" panose="02040503050406030204" pitchFamily="18" charset="0"/>
+                          </a:rPr>
+                          <m:t>10</m:t>
+                        </m:r>
+                      </m:sub>
+                    </m:sSub>
+                  </m:oMath>
+                </a14:m>
+                <a:r>
+                  <a:rPr lang="en-GB" dirty="0"/>
+                  <a:t> is missing, </a:t>
+                </a:r>
+                <a14:m>
+                  <m:oMath xmlns:m="http://schemas.openxmlformats.org/officeDocument/2006/math">
+                    <m:acc>
+                      <m:accPr>
+                        <m:chr m:val="̂"/>
+                        <m:ctrlPr>
+                          <a:rPr lang="en-GB" i="1" dirty="0">
+                            <a:latin typeface="Cambria Math" panose="02040503050406030204" pitchFamily="18" charset="0"/>
+                          </a:rPr>
+                        </m:ctrlPr>
+                      </m:accPr>
+                      <m:e>
+                        <m:sSub>
+                          <m:sSubPr>
+                            <m:ctrlPr>
+                              <a:rPr lang="en-GB" b="0" i="1" dirty="0" smtClean="0">
+                                <a:latin typeface="Cambria Math" panose="02040503050406030204" pitchFamily="18" charset="0"/>
+                              </a:rPr>
+                            </m:ctrlPr>
+                          </m:sSubPr>
+                          <m:e>
+                            <m:r>
+                              <a:rPr lang="en-GB" b="0" i="1" dirty="0" smtClean="0">
+                                <a:latin typeface="Cambria Math" panose="02040503050406030204" pitchFamily="18" charset="0"/>
+                              </a:rPr>
+                              <m:t>𝑑</m:t>
+                            </m:r>
+                          </m:e>
+                          <m:sub>
+                            <m:r>
+                              <a:rPr lang="en-GB" b="0" i="1" dirty="0" smtClean="0">
+                                <a:latin typeface="Cambria Math" panose="02040503050406030204" pitchFamily="18" charset="0"/>
+                              </a:rPr>
+                              <m:t>10</m:t>
+                            </m:r>
+                          </m:sub>
+                        </m:sSub>
+                      </m:e>
+                    </m:acc>
+                  </m:oMath>
+                </a14:m>
+                <a:r>
+                  <a:rPr lang="en-GB" dirty="0"/>
+                  <a:t> is missing</a:t>
+                </a:r>
+              </a:p>
+              <a:p>
+                <a:r>
+                  <a:rPr lang="en-GB" dirty="0"/>
+                  <a:t>Case 2: </a:t>
+                </a:r>
+                <a14:m>
+                  <m:oMath xmlns:m="http://schemas.openxmlformats.org/officeDocument/2006/math">
+                    <m:sSub>
+                      <m:sSubPr>
+                        <m:ctrlPr>
+                          <a:rPr lang="en-GB" b="0" i="1" smtClean="0">
+                            <a:latin typeface="Cambria Math" panose="02040503050406030204" pitchFamily="18" charset="0"/>
+                          </a:rPr>
+                        </m:ctrlPr>
+                      </m:sSubPr>
+                      <m:e>
+                        <m:r>
+                          <m:rPr>
+                            <m:sty m:val="p"/>
+                          </m:rPr>
+                          <a:rPr lang="en-GB" b="0" i="0" smtClean="0">
+                            <a:latin typeface="Cambria Math" panose="02040503050406030204" pitchFamily="18" charset="0"/>
+                          </a:rPr>
+                          <m:t>e</m:t>
+                        </m:r>
+                      </m:e>
+                      <m:sub>
+                        <m:r>
+                          <a:rPr lang="en-GB" b="0" i="0" smtClean="0">
+                            <a:latin typeface="Cambria Math" panose="02040503050406030204" pitchFamily="18" charset="0"/>
+                          </a:rPr>
+                          <m:t>10</m:t>
+                        </m:r>
+                      </m:sub>
+                    </m:sSub>
+                  </m:oMath>
+                </a14:m>
+                <a:r>
+                  <a:rPr lang="en-GB" dirty="0"/>
+                  <a:t> is missing, </a:t>
+                </a:r>
+                <a14:m>
+                  <m:oMath xmlns:m="http://schemas.openxmlformats.org/officeDocument/2006/math">
+                    <m:sSub>
+                      <m:sSubPr>
+                        <m:ctrlPr>
+                          <a:rPr lang="en-GB" b="0" i="1" smtClean="0">
+                            <a:latin typeface="Cambria Math" panose="02040503050406030204" pitchFamily="18" charset="0"/>
+                          </a:rPr>
+                        </m:ctrlPr>
+                      </m:sSubPr>
+                      <m:e>
+                        <m:r>
+                          <a:rPr lang="en-GB" b="0" i="1" smtClean="0">
+                            <a:latin typeface="Cambria Math" panose="02040503050406030204" pitchFamily="18" charset="0"/>
+                          </a:rPr>
+                          <m:t>𝑑</m:t>
+                        </m:r>
+                      </m:e>
+                      <m:sub>
+                        <m:r>
+                          <a:rPr lang="en-GB" b="0" i="1" smtClean="0">
+                            <a:latin typeface="Cambria Math" panose="02040503050406030204" pitchFamily="18" charset="0"/>
+                          </a:rPr>
+                          <m:t>10</m:t>
+                        </m:r>
+                      </m:sub>
+                    </m:sSub>
+                  </m:oMath>
+                </a14:m>
+                <a:r>
+                  <a:rPr lang="en-GB" dirty="0"/>
+                  <a:t> is available, hence </a:t>
+                </a:r>
+                <a14:m>
+                  <m:oMath xmlns:m="http://schemas.openxmlformats.org/officeDocument/2006/math">
+                    <m:acc>
+                      <m:accPr>
+                        <m:chr m:val="̂"/>
+                        <m:ctrlPr>
+                          <a:rPr lang="en-GB" b="0" i="1" dirty="0" smtClean="0">
+                            <a:latin typeface="Cambria Math" panose="02040503050406030204" pitchFamily="18" charset="0"/>
+                          </a:rPr>
+                        </m:ctrlPr>
+                      </m:accPr>
+                      <m:e>
+                        <m:r>
+                          <a:rPr lang="en-GB" b="0" i="1" dirty="0" smtClean="0">
+                            <a:latin typeface="Cambria Math" panose="02040503050406030204" pitchFamily="18" charset="0"/>
+                          </a:rPr>
+                          <m:t>𝑑</m:t>
+                        </m:r>
+                      </m:e>
+                    </m:acc>
+                  </m:oMath>
+                </a14:m>
+                <a:r>
+                  <a:rPr lang="en-GB" dirty="0"/>
+                  <a:t> is missing</a:t>
+                </a:r>
+              </a:p>
+              <a:p>
+                <a:r>
+                  <a:rPr lang="en-GB" dirty="0"/>
+                  <a:t>Case 3: </a:t>
+                </a:r>
+                <a14:m>
+                  <m:oMath xmlns:m="http://schemas.openxmlformats.org/officeDocument/2006/math">
+                    <m:sSub>
+                      <m:sSubPr>
+                        <m:ctrlPr>
+                          <a:rPr lang="en-GB" b="0" i="1" smtClean="0">
+                            <a:latin typeface="Cambria Math" panose="02040503050406030204" pitchFamily="18" charset="0"/>
+                          </a:rPr>
+                        </m:ctrlPr>
+                      </m:sSubPr>
+                      <m:e>
+                        <m:r>
+                          <a:rPr lang="en-GB" b="0" i="1" smtClean="0">
+                            <a:latin typeface="Cambria Math" panose="02040503050406030204" pitchFamily="18" charset="0"/>
+                          </a:rPr>
+                          <m:t>𝑑</m:t>
+                        </m:r>
+                      </m:e>
+                      <m:sub>
+                        <m:r>
+                          <a:rPr lang="en-GB" b="0" i="1" smtClean="0">
+                            <a:latin typeface="Cambria Math" panose="02040503050406030204" pitchFamily="18" charset="0"/>
+                          </a:rPr>
+                          <m:t>10</m:t>
+                        </m:r>
+                      </m:sub>
+                    </m:sSub>
+                  </m:oMath>
+                </a14:m>
+                <a:r>
+                  <a:rPr lang="en-GB" dirty="0"/>
+                  <a:t> and </a:t>
+                </a:r>
+                <a14:m>
+                  <m:oMath xmlns:m="http://schemas.openxmlformats.org/officeDocument/2006/math">
+                    <m:sSub>
+                      <m:sSubPr>
+                        <m:ctrlPr>
+                          <a:rPr lang="en-GB" b="0" i="1" smtClean="0">
+                            <a:latin typeface="Cambria Math" panose="02040503050406030204" pitchFamily="18" charset="0"/>
+                          </a:rPr>
+                        </m:ctrlPr>
+                      </m:sSubPr>
+                      <m:e>
+                        <m:r>
+                          <a:rPr lang="en-GB" b="0" i="1" smtClean="0">
+                            <a:latin typeface="Cambria Math" panose="02040503050406030204" pitchFamily="18" charset="0"/>
+                          </a:rPr>
+                          <m:t>𝑒</m:t>
+                        </m:r>
+                      </m:e>
+                      <m:sub>
+                        <m:r>
+                          <a:rPr lang="en-GB" b="0" i="1" smtClean="0">
+                            <a:latin typeface="Cambria Math" panose="02040503050406030204" pitchFamily="18" charset="0"/>
+                          </a:rPr>
+                          <m:t>10</m:t>
+                        </m:r>
+                      </m:sub>
+                    </m:sSub>
+                  </m:oMath>
+                </a14:m>
+                <a:r>
+                  <a:rPr lang="en-GB" dirty="0"/>
+                  <a:t>are both missing</a:t>
+                </a:r>
+              </a:p>
+              <a:p>
+                <a:endParaRPr lang="en-GB" dirty="0"/>
+              </a:p>
+            </p:txBody>
+          </p:sp>
+        </mc:Choice>
+        <mc:Fallback xmlns="">
+          <p:sp>
+            <p:nvSpPr>
+              <p:cNvPr id="3" name="Content Placeholder 2">
+                <a:extLst>
+                  <a:ext uri="{FF2B5EF4-FFF2-40B4-BE49-F238E27FC236}">
+                    <a16:creationId xmlns:a16="http://schemas.microsoft.com/office/drawing/2014/main" id="{60EBC197-E8FD-D126-2B4E-7651A173415A}"/>
+                  </a:ext>
+                </a:extLst>
+              </p:cNvPr>
+              <p:cNvSpPr>
+                <a:spLocks noGrp="1" noRot="1" noChangeAspect="1" noMove="1" noResize="1" noEditPoints="1" noAdjustHandles="1" noChangeArrowheads="1" noChangeShapeType="1" noTextEdit="1"/>
+              </p:cNvSpPr>
+              <p:nvPr>
+                <p:ph idx="1"/>
+              </p:nvPr>
+            </p:nvSpPr>
+            <p:spPr>
+              <a:blipFill>
+                <a:blip r:embed="rId2"/>
+                <a:stretch>
+                  <a:fillRect l="-1043" t="-2241"/>
+                </a:stretch>
+              </a:blipFill>
+            </p:spPr>
+            <p:txBody>
+              <a:bodyPr/>
+              <a:lstStyle/>
+              <a:p>
+                <a:r>
+                  <a:rPr lang="en-GB">
+                    <a:noFill/>
+                  </a:rPr>
+                  <a:t> </a:t>
+                </a:r>
+              </a:p>
+            </p:txBody>
+          </p:sp>
+        </mc:Fallback>
+      </mc:AlternateContent>
+    </p:spTree>
+    <p:extLst>
+      <p:ext uri="{BB962C8B-B14F-4D97-AF65-F5344CB8AC3E}">
+        <p14:creationId xmlns:p14="http://schemas.microsoft.com/office/powerpoint/2010/main" val="1969600650"/>
+      </p:ext>
+    </p:extLst>
+  </p:cSld>
+  <p:clrMapOvr>
+    <a:masterClrMapping/>
+  </p:clrMapOvr>
+</p:sld>
+</file>
+
 <file path=ppt/theme/theme1.xml><?xml version="1.0" encoding="utf-8"?>
 <a:theme xmlns:a="http://schemas.openxmlformats.org/drawingml/2006/main" name="Office Theme">
   <a:themeElements>

</xml_diff>